<commit_message>
Update room to Aula E14
Co-Authored-By: claude-flow <ruv@ruv.net>
</commit_message>
<xml_diff>
--- a/flyer/IV_Jornadas_DiD_flyer.pptx
+++ b/flyer/IV_Jornadas_DiD_flyer.pptx
@@ -4,14 +4,14 @@
   <p:sldMasterIdLst>
     <p:sldMasterId id="2147483648" r:id="rId1"/>
   </p:sldMasterIdLst>
+  <p:notesMasterIdLst>
+    <p:notesMasterId r:id="rId3"/>
+  </p:notesMasterIdLst>
   <p:sldIdLst>
     <p:sldId id="256" r:id="rId2"/>
   </p:sldIdLst>
-  <p:notesMasterIdLst>
-    <p:notesMasterId r:id="rId3"/>
-  </p:notesMasterIdLst>
-  <p:sldSz cx="6858000" cy="6903720"/>
-  <p:notesSz cx="6903720" cy="6858000"/>
+  <p:sldSz cx="6858000" cy="6904038"/>
+  <p:notesSz cx="6904038" cy="6858000"/>
   <p:defaultTextStyle>
     <a:lvl1pPr marL="0" algn="l" defTabSz="914400" rtl="0" eaLnBrk="1" latinLnBrk="0" hangingPunct="1">
       <a:defRPr sz="1800" kern="1200">
@@ -104,6 +104,11 @@
       </a:defRPr>
     </a:lvl9pPr>
   </p:defaultTextStyle>
+  <p:extLst>
+    <p:ext uri="{EFAFB233-063F-42B5-8137-9DF3F51BA10A}">
+      <p15:sldGuideLst xmlns:p15="http://schemas.microsoft.com/office/powerpoint/2012/main"/>
+    </p:ext>
+  </p:extLst>
 </p:presentation>
 </file>
 
@@ -129,234 +134,10 @@
           <a:chExt cx="0" cy="0"/>
         </a:xfrm>
       </p:grpSpPr>
-      <p:sp>
-        <p:nvSpPr>
-          <p:cNvPr id="2" name="Header Placeholder 1"/>
-          <p:cNvSpPr>
-            <a:spLocks noGrp="1"/>
-          </p:cNvSpPr>
-          <p:nvPr>
-            <p:ph type="hdr" sz="quarter"/>
-          </p:nvPr>
-        </p:nvSpPr>
-        <p:spPr>
-          <a:xfrm>
-            <a:off x="0" y="0"/>
-            <a:ext cx="2971800" cy="458788"/>
-          </a:xfrm>
-          <a:prstGeom prst="rect">
-            <a:avLst/>
-          </a:prstGeom>
-        </p:spPr>
-        <p:txBody>
-          <a:bodyPr vert="horz" lIns="91440" tIns="45720" rIns="91440" bIns="45720" rtlCol="0"/>
-          <a:lstStyle>
-            <a:lvl1pPr algn="l">
-              <a:defRPr sz="1200"/>
-            </a:lvl1pPr>
-          </a:lstStyle>
-          <a:p>
-            <a:endParaRPr lang="en-US"/>
-          </a:p>
-        </p:txBody>
-      </p:sp>
-      <p:sp>
-        <p:nvSpPr>
-          <p:cNvPr id="3" name="Date Placeholder 2"/>
-          <p:cNvSpPr>
-            <a:spLocks noGrp="1"/>
-          </p:cNvSpPr>
-          <p:nvPr>
-            <p:ph type="dt" idx="1"/>
-          </p:nvPr>
-        </p:nvSpPr>
-        <p:spPr>
-          <a:xfrm>
-            <a:off x="3884613" y="0"/>
-            <a:ext cx="2971800" cy="458788"/>
-          </a:xfrm>
-          <a:prstGeom prst="rect">
-            <a:avLst/>
-          </a:prstGeom>
-        </p:spPr>
-        <p:txBody>
-          <a:bodyPr vert="horz" lIns="91440" tIns="45720" rIns="91440" bIns="45720" rtlCol="0"/>
-          <a:lstStyle>
-            <a:lvl1pPr algn="r">
-              <a:defRPr sz="1200"/>
-            </a:lvl1pPr>
-          </a:lstStyle>
-          <a:p>
-            <a:fld id="{5282F153-3F37-0F45-9E97-73ACFA13230C}" type="datetimeFigureOut">
-              <a:rPr lang="en-US"/>
-              <a:t>7/23/19</a:t>
-            </a:fld>
-            <a:endParaRPr lang="en-US"/>
-          </a:p>
-        </p:txBody>
-      </p:sp>
-      <p:sp>
-        <p:nvSpPr>
-          <p:cNvPr id="4" name="Slide Image Placeholder 3"/>
-          <p:cNvSpPr>
-            <a:spLocks noGrp="1" noRot="1" noChangeAspect="1"/>
-          </p:cNvSpPr>
-          <p:nvPr>
-            <p:ph type="sldImg" idx="2"/>
-          </p:nvPr>
-        </p:nvSpPr>
-        <p:spPr>
-          <a:xfrm>
-            <a:off x="685800" y="1143000"/>
-            <a:ext cx="5486400" cy="3086100"/>
-          </a:xfrm>
-          <a:prstGeom prst="rect">
-            <a:avLst/>
-          </a:prstGeom>
-          <a:noFill/>
-          <a:ln w="12700">
-            <a:solidFill>
-              <a:prstClr val="black"/>
-            </a:solidFill>
-          </a:ln>
-        </p:spPr>
-        <p:txBody>
-          <a:bodyPr vert="horz" lIns="91440" tIns="45720" rIns="91440" bIns="45720" rtlCol="0" anchor="ctr"/>
-          <a:lstStyle/>
-          <a:p>
-            <a:endParaRPr lang="en-US"/>
-          </a:p>
-        </p:txBody>
-      </p:sp>
-      <p:sp>
-        <p:nvSpPr>
-          <p:cNvPr id="5" name="Notes Placeholder 4"/>
-          <p:cNvSpPr>
-            <a:spLocks noGrp="1"/>
-          </p:cNvSpPr>
-          <p:nvPr>
-            <p:ph type="body" sz="quarter" idx="3"/>
-          </p:nvPr>
-        </p:nvSpPr>
-        <p:spPr>
-          <a:xfrm>
-            <a:off x="685800" y="4400550"/>
-            <a:ext cx="5486400" cy="3600450"/>
-          </a:xfrm>
-          <a:prstGeom prst="rect">
-            <a:avLst/>
-          </a:prstGeom>
-        </p:spPr>
-        <p:txBody>
-          <a:bodyPr vert="horz" lIns="91440" tIns="45720" rIns="91440" bIns="45720" rtlCol="0"/>
-          <a:lstStyle/>
-          <a:p>
-            <a:pPr lvl="0"/>
-            <a:r>
-              <a:rPr lang="en-US"/>
-              <a:t>Click to edit Master text styles</a:t>
-            </a:r>
-          </a:p>
-          <a:p>
-            <a:pPr lvl="1"/>
-            <a:r>
-              <a:rPr lang="en-US"/>
-              <a:t>Second level</a:t>
-            </a:r>
-          </a:p>
-          <a:p>
-            <a:pPr lvl="2"/>
-            <a:r>
-              <a:rPr lang="en-US"/>
-              <a:t>Third level</a:t>
-            </a:r>
-          </a:p>
-          <a:p>
-            <a:pPr lvl="3"/>
-            <a:r>
-              <a:rPr lang="en-US"/>
-              <a:t>Fourth level</a:t>
-            </a:r>
-          </a:p>
-          <a:p>
-            <a:pPr lvl="4"/>
-            <a:r>
-              <a:rPr lang="en-US"/>
-              <a:t>Fifth level</a:t>
-            </a:r>
-          </a:p>
-        </p:txBody>
-      </p:sp>
-      <p:sp>
-        <p:nvSpPr>
-          <p:cNvPr id="6" name="Footer Placeholder 5"/>
-          <p:cNvSpPr>
-            <a:spLocks noGrp="1"/>
-          </p:cNvSpPr>
-          <p:nvPr>
-            <p:ph type="ftr" sz="quarter" idx="4"/>
-          </p:nvPr>
-        </p:nvSpPr>
-        <p:spPr>
-          <a:xfrm>
-            <a:off x="0" y="8685213"/>
-            <a:ext cx="2971800" cy="458787"/>
-          </a:xfrm>
-          <a:prstGeom prst="rect">
-            <a:avLst/>
-          </a:prstGeom>
-        </p:spPr>
-        <p:txBody>
-          <a:bodyPr vert="horz" lIns="91440" tIns="45720" rIns="91440" bIns="45720" rtlCol="0" anchor="b"/>
-          <a:lstStyle>
-            <a:lvl1pPr algn="l">
-              <a:defRPr sz="1200"/>
-            </a:lvl1pPr>
-          </a:lstStyle>
-          <a:p>
-            <a:endParaRPr lang="en-US"/>
-          </a:p>
-        </p:txBody>
-      </p:sp>
-      <p:sp>
-        <p:nvSpPr>
-          <p:cNvPr id="7" name="Slide Number Placeholder 6"/>
-          <p:cNvSpPr>
-            <a:spLocks noGrp="1"/>
-          </p:cNvSpPr>
-          <p:nvPr>
-            <p:ph type="sldNum" sz="quarter" idx="5"/>
-          </p:nvPr>
-        </p:nvSpPr>
-        <p:spPr>
-          <a:xfrm>
-            <a:off x="3884613" y="8685213"/>
-            <a:ext cx="2971800" cy="458787"/>
-          </a:xfrm>
-          <a:prstGeom prst="rect">
-            <a:avLst/>
-          </a:prstGeom>
-        </p:spPr>
-        <p:txBody>
-          <a:bodyPr vert="horz" lIns="91440" tIns="45720" rIns="91440" bIns="45720" rtlCol="0" anchor="b"/>
-          <a:lstStyle>
-            <a:lvl1pPr algn="r">
-              <a:defRPr sz="1200"/>
-            </a:lvl1pPr>
-          </a:lstStyle>
-          <a:p>
-            <a:fld id="{CE5E9CC1-C706-0F49-92D6-E571CC5EEA8F}" type="slidenum">
-              <a:rPr lang="en-US"/>
-              <a:t>‹#›</a:t>
-            </a:fld>
-            <a:endParaRPr lang="en-US"/>
-          </a:p>
-        </p:txBody>
-      </p:sp>
     </p:spTree>
     <p:extLst>
       <p:ext uri="{BB962C8B-B14F-4D97-AF65-F5344CB8AC3E}">
-        <p14:creationId xmlns:p14="http://schemas.microsoft.com/office/powerpoint/2010/main" val="1024086991"/>
+        <p14:creationId xmlns:p14="http://schemas.microsoft.com/office/powerpoint/2010/main" val="73973763"/>
       </p:ext>
     </p:extLst>
   </p:cSld>
@@ -500,10 +281,6 @@
           <a:bodyPr/>
           <a:lstStyle/>
           <a:p>
-            <a:r>
-              <a:rPr lang="en-US" dirty="0"/>
-              <a:t/>
-            </a:r>
             <a:endParaRPr lang="en-US" dirty="0"/>
           </a:p>
         </p:txBody>
@@ -577,6 +354,11 @@
 <file path=ppt/slideMasters/slideMaster1.xml><?xml version="1.0" encoding="utf-8"?>
 <p:sldMaster xmlns:a="http://schemas.openxmlformats.org/drawingml/2006/main" xmlns:r="http://schemas.openxmlformats.org/officeDocument/2006/relationships" xmlns:p="http://schemas.openxmlformats.org/presentationml/2006/main">
   <p:cSld>
+    <p:bg>
+      <p:bgRef idx="1001">
+        <a:schemeClr val="bg1"/>
+      </p:bgRef>
+    </p:bg>
     <p:spTree>
       <p:nvGrpSpPr>
         <p:cNvPr id="1" name=""/>
@@ -859,6 +641,7 @@
         <a:solidFill>
           <a:srgbClr val="FFFFFF"/>
         </a:solidFill>
+        <a:effectLst/>
       </p:bgPr>
     </p:bg>
     <p:spTree>
@@ -905,7 +688,10 @@
         </p:spPr>
         <p:txBody>
           <a:bodyPr/>
-          <a:p/>
+          <a:lstStyle/>
+          <a:p>
+            <a:endParaRPr/>
+          </a:p>
         </p:txBody>
       </p:sp>
       <p:sp>
@@ -938,7 +724,10 @@
         </p:spPr>
         <p:txBody>
           <a:bodyPr/>
-          <a:p/>
+          <a:lstStyle/>
+          <a:p>
+            <a:endParaRPr/>
+          </a:p>
         </p:txBody>
       </p:sp>
       <p:sp>
@@ -971,7 +760,10 @@
         </p:spPr>
         <p:txBody>
           <a:bodyPr/>
-          <a:p/>
+          <a:lstStyle/>
+          <a:p>
+            <a:endParaRPr/>
+          </a:p>
         </p:txBody>
       </p:sp>
       <p:sp>
@@ -1048,7 +840,7 @@
             <a:prstDash val="solid"/>
           </a:ln>
           <a:effectLst>
-            <a:outerShdw sx="100000" sy="100000" kx="0" ky="0" algn="bl" rotWithShape="0" blurRad="12700" dist="50800" dir="2700000">
+            <a:outerShdw blurRad="12700" dist="50800" dir="2700000" algn="bl" rotWithShape="0">
               <a:srgbClr val="FFD0A8">
                 <a:alpha val="25000"/>
               </a:srgbClr>
@@ -1057,7 +849,10 @@
         </p:spPr>
         <p:txBody>
           <a:bodyPr/>
-          <a:p/>
+          <a:lstStyle/>
+          <a:p>
+            <a:endParaRPr/>
+          </a:p>
         </p:txBody>
       </p:sp>
       <p:sp>
@@ -1083,7 +878,7 @@
           </a:bodyPr>
           <a:lstStyle/>
           <a:p>
-            <a:pPr algn="ctr" indent="0" marL="0">
+            <a:pPr marL="0" indent="0" algn="ctr">
               <a:buNone/>
             </a:pPr>
             <a:r>
@@ -1122,7 +917,7 @@
           <a:bodyPr wrap="square" lIns="0" tIns="0" rIns="0" bIns="0" rtlCol="0" anchor="ctr"/>
           <a:lstStyle/>
           <a:p>
-            <a:pPr indent="0" marL="0">
+            <a:pPr marL="0" indent="0">
               <a:buNone/>
             </a:pPr>
             <a:r>
@@ -1164,7 +959,10 @@
         </p:spPr>
         <p:txBody>
           <a:bodyPr/>
-          <a:p/>
+          <a:lstStyle/>
+          <a:p>
+            <a:endParaRPr/>
+          </a:p>
         </p:txBody>
       </p:sp>
       <p:sp>
@@ -1193,7 +991,7 @@
             <a:prstDash val="solid"/>
           </a:ln>
           <a:effectLst>
-            <a:outerShdw sx="100000" sy="100000" kx="0" ky="0" algn="bl" rotWithShape="0" blurRad="25400" dist="50800" dir="2700000">
+            <a:outerShdw blurRad="25400" dist="50800" dir="2700000" algn="bl" rotWithShape="0">
               <a:srgbClr val="BCA28B">
                 <a:alpha val="23000"/>
               </a:srgbClr>
@@ -1202,20 +1000,23 @@
         </p:spPr>
         <p:txBody>
           <a:bodyPr/>
-          <a:p/>
+          <a:lstStyle/>
+          <a:p>
+            <a:endParaRPr/>
+          </a:p>
         </p:txBody>
       </p:sp>
       <p:pic>
         <p:nvPicPr>
-          <p:cNvPr id="11" name="Image 0" descr="/mnt/data/user-kFxlzeVC9OKOiqKtRZPm51O9/56124a42078b40f891e0679f857fd628/mnt/data/media/ppt/media/image4.jpg">    </p:cNvPr>
+          <p:cNvPr id="11" name="Image 0" descr="/mnt/data/user-kFxlzeVC9OKOiqKtRZPm51O9/56124a42078b40f891e0679f857fd628/mnt/data/media/ppt/media/image4.jpg"/>
           <p:cNvPicPr>
             <a:picLocks noChangeAspect="1"/>
           </p:cNvPicPr>
           <p:nvPr/>
         </p:nvPicPr>
         <p:blipFill>
-          <a:blip r:embed="rId1"/>
-          <a:srcRect l="0" r="0" t="2392" b="2392"/>
+          <a:blip r:embed="rId3"/>
+          <a:srcRect t="2392" b="2392"/>
           <a:stretch/>
         </p:blipFill>
         <p:spPr>
@@ -1252,7 +1053,10 @@
         </p:spPr>
         <p:txBody>
           <a:bodyPr/>
-          <a:p/>
+          <a:lstStyle/>
+          <a:p>
+            <a:endParaRPr/>
+          </a:p>
         </p:txBody>
       </p:sp>
       <p:sp>
@@ -1283,7 +1087,7 @@
             <a:prstDash val="solid"/>
           </a:ln>
           <a:effectLst>
-            <a:outerShdw sx="100000" sy="100000" kx="0" ky="0" algn="bl" rotWithShape="0" blurRad="12700" dist="50800" dir="2700000">
+            <a:outerShdw blurRad="12700" dist="50800" dir="2700000" algn="bl" rotWithShape="0">
               <a:srgbClr val="F6D1BA">
                 <a:alpha val="18000"/>
               </a:srgbClr>
@@ -1292,7 +1096,10 @@
         </p:spPr>
         <p:txBody>
           <a:bodyPr/>
-          <a:p/>
+          <a:lstStyle/>
+          <a:p>
+            <a:endParaRPr/>
+          </a:p>
         </p:txBody>
       </p:sp>
       <p:sp>
@@ -1318,7 +1125,7 @@
           </a:bodyPr>
           <a:lstStyle/>
           <a:p>
-            <a:pPr indent="0" marL="0">
+            <a:pPr marL="0" indent="0">
               <a:buNone/>
             </a:pPr>
             <a:r>
@@ -1406,7 +1213,10 @@
         </p:spPr>
         <p:txBody>
           <a:bodyPr/>
-          <a:p/>
+          <a:lstStyle/>
+          <a:p>
+            <a:endParaRPr/>
+          </a:p>
         </p:txBody>
       </p:sp>
       <p:sp>
@@ -1439,7 +1249,7 @@
             <a:prstDash val="solid"/>
           </a:ln>
           <a:effectLst>
-            <a:outerShdw sx="100000" sy="100000" kx="0" ky="0" algn="bl" rotWithShape="0" blurRad="25400" dist="50800" dir="2700000">
+            <a:outerShdw blurRad="25400" dist="50800" dir="2700000" algn="bl" rotWithShape="0">
               <a:srgbClr val="FFD2AB">
                 <a:alpha val="19000"/>
               </a:srgbClr>
@@ -1448,7 +1258,10 @@
         </p:spPr>
         <p:txBody>
           <a:bodyPr/>
-          <a:p/>
+          <a:lstStyle/>
+          <a:p>
+            <a:endParaRPr/>
+          </a:p>
         </p:txBody>
       </p:sp>
       <p:sp>
@@ -1472,7 +1285,7 @@
           <a:bodyPr wrap="square" lIns="0" tIns="0" rIns="0" bIns="0" rtlCol="0" anchor="ctr"/>
           <a:lstStyle/>
           <a:p>
-            <a:pPr algn="ctr" indent="0" marL="0">
+            <a:pPr marL="0" indent="0" algn="ctr">
               <a:buNone/>
             </a:pPr>
             <a:r>
@@ -1508,7 +1321,7 @@
           <a:bodyPr wrap="square" lIns="0" tIns="0" rIns="0" bIns="0" rtlCol="0" anchor="ctr"/>
           <a:lstStyle/>
           <a:p>
-            <a:pPr indent="0" marL="0">
+            <a:pPr marL="0" indent="0">
               <a:buNone/>
             </a:pPr>
             <a:r>
@@ -1547,7 +1360,7 @@
           <a:bodyPr wrap="square" lIns="0" tIns="0" rIns="0" bIns="0" rtlCol="0" anchor="ctr"/>
           <a:lstStyle/>
           <a:p>
-            <a:pPr algn="ctr" indent="0" marL="0">
+            <a:pPr marL="0" indent="0" algn="ctr">
               <a:buNone/>
             </a:pPr>
             <a:r>
@@ -1592,7 +1405,7 @@
                 </a:solidFill>
                 <a:latin typeface="Aptos"/>
               </a:rPr>
-              <a:t>10:00-14:00 horas en el aula D11 de la</a:t>
+              <a:t>10:00-14:00 horas en el aula E14 de la</a:t>
             </a:r>
           </a:p>
           <a:p>
@@ -1672,7 +1485,10 @@
         </p:spPr>
         <p:txBody>
           <a:bodyPr/>
-          <a:p/>
+          <a:lstStyle/>
+          <a:p>
+            <a:endParaRPr/>
+          </a:p>
         </p:txBody>
       </p:sp>
       <p:sp>
@@ -1698,7 +1514,7 @@
           </a:bodyPr>
           <a:lstStyle/>
           <a:p>
-            <a:pPr indent="0" marL="0">
+            <a:pPr marL="0" indent="0">
               <a:buNone/>
             </a:pPr>
             <a:r>
@@ -1739,7 +1555,7 @@
           </a:bodyPr>
           <a:lstStyle/>
           <a:p>
-            <a:pPr indent="0" marL="0">
+            <a:pPr marL="0" indent="0">
               <a:buNone/>
             </a:pPr>
             <a:r>
@@ -1757,31 +1573,7 @@
       </p:sp>
       <p:pic>
         <p:nvPicPr>
-          <p:cNvPr id="26" name="Image 1" descr="/mnt/data/user-kFxlzeVC9OKOiqKtRZPm51O9/56124a42078b40f891e0679f857fd628/mnt/data/media/ppt/media/image1.png">    </p:cNvPr>
-          <p:cNvPicPr>
-            <a:picLocks noChangeAspect="1"/>
-          </p:cNvPicPr>
-          <p:nvPr/>
-        </p:nvPicPr>
-        <p:blipFill>
-          <a:blip r:embed="rId3"/>
-          <a:stretch>
-            <a:fillRect/>
-          </a:stretch>
-        </p:blipFill>
-        <p:spPr>
-          <a:xfrm>
-            <a:off x="246888" y="6254496"/>
-            <a:ext cx="749808" cy="502920"/>
-          </a:xfrm>
-          <a:prstGeom prst="rect">
-            <a:avLst/>
-          </a:prstGeom>
-        </p:spPr>
-      </p:pic>
-      <p:pic>
-        <p:nvPicPr>
-          <p:cNvPr id="27" name="Image 2" descr="/mnt/data/user-kFxlzeVC9OKOiqKtRZPm51O9/56124a42078b40f891e0679f857fd628/mnt/data/media/ppt/media/image2.png">    </p:cNvPr>
+          <p:cNvPr id="26" name="Image 1" descr="/mnt/data/user-kFxlzeVC9OKOiqKtRZPm51O9/56124a42078b40f891e0679f857fd628/mnt/data/media/ppt/media/image1.png"/>
           <p:cNvPicPr>
             <a:picLocks noChangeAspect="1"/>
           </p:cNvPicPr>
@@ -1795,8 +1587,8 @@
         </p:blipFill>
         <p:spPr>
           <a:xfrm>
-            <a:off x="2505456" y="6327648"/>
-            <a:ext cx="1673352" cy="475488"/>
+            <a:off x="246888" y="6254496"/>
+            <a:ext cx="749808" cy="502920"/>
           </a:xfrm>
           <a:prstGeom prst="rect">
             <a:avLst/>
@@ -1805,7 +1597,7 @@
       </p:pic>
       <p:pic>
         <p:nvPicPr>
-          <p:cNvPr id="28" name="Image 3" descr="/mnt/data/user-kFxlzeVC9OKOiqKtRZPm51O9/56124a42078b40f891e0679f857fd628/mnt/data/media/ppt/media/image3.png">    </p:cNvPr>
+          <p:cNvPr id="27" name="Image 2" descr="/mnt/data/user-kFxlzeVC9OKOiqKtRZPm51O9/56124a42078b40f891e0679f857fd628/mnt/data/media/ppt/media/image2.png"/>
           <p:cNvPicPr>
             <a:picLocks noChangeAspect="1"/>
           </p:cNvPicPr>
@@ -1819,6 +1611,30 @@
         </p:blipFill>
         <p:spPr>
           <a:xfrm>
+            <a:off x="2505456" y="6327648"/>
+            <a:ext cx="1673352" cy="475488"/>
+          </a:xfrm>
+          <a:prstGeom prst="rect">
+            <a:avLst/>
+          </a:prstGeom>
+        </p:spPr>
+      </p:pic>
+      <p:pic>
+        <p:nvPicPr>
+          <p:cNvPr id="28" name="Image 3" descr="/mnt/data/user-kFxlzeVC9OKOiqKtRZPm51O9/56124a42078b40f891e0679f857fd628/mnt/data/media/ppt/media/image3.png"/>
+          <p:cNvPicPr>
+            <a:picLocks noChangeAspect="1"/>
+          </p:cNvPicPr>
+          <p:nvPr/>
+        </p:nvPicPr>
+        <p:blipFill>
+          <a:blip r:embed="rId6"/>
+          <a:stretch>
+            <a:fillRect/>
+          </a:stretch>
+        </p:blipFill>
+        <p:spPr>
+          <a:xfrm>
             <a:off x="4983480" y="6300216"/>
             <a:ext cx="1609344" cy="475488"/>
           </a:xfrm>
@@ -1853,7 +1669,7 @@
             <a:prstDash val="solid"/>
           </a:ln>
           <a:effectLst>
-            <a:outerShdw sx="100000" sy="100000" kx="0" ky="0" algn="tl" rotWithShape="0" blurRad="25400" dist="30480" dir="5400000">
+            <a:outerShdw blurRad="25400" dist="30480" dir="5400000" algn="tl" rotWithShape="0">
               <a:srgbClr val="BCA28B">
                 <a:alpha val="22000"/>
               </a:srgbClr>
@@ -1862,7 +1678,10 @@
         </p:spPr>
         <p:txBody>
           <a:bodyPr/>
-          <a:p/>
+          <a:lstStyle/>
+          <a:p>
+            <a:endParaRPr/>
+          </a:p>
         </p:txBody>
       </p:sp>
       <p:pic>
@@ -1874,7 +1693,7 @@
           <p:nvPr/>
         </p:nvPicPr>
         <p:blipFill>
-          <a:blip r:embed="rId8"/>
+          <a:blip r:embed="rId7"/>
           <a:stretch>
             <a:fillRect/>
           </a:stretch>
@@ -2190,4 +2009,319 @@
     </a:ext>
   </a:extLst>
 </a:theme>
+</file>
+
+<file path=ppt/theme/theme2.xml><?xml version="1.0" encoding="utf-8"?>
+<a:theme xmlns:a="http://schemas.openxmlformats.org/drawingml/2006/main" name="Tema de Office">
+  <a:themeElements>
+    <a:clrScheme name="Office">
+      <a:dk1>
+        <a:sysClr val="windowText" lastClr="000000"/>
+      </a:dk1>
+      <a:lt1>
+        <a:sysClr val="window" lastClr="FFFFFF"/>
+      </a:lt1>
+      <a:dk2>
+        <a:srgbClr val="0E2841"/>
+      </a:dk2>
+      <a:lt2>
+        <a:srgbClr val="E8E8E8"/>
+      </a:lt2>
+      <a:accent1>
+        <a:srgbClr val="156082"/>
+      </a:accent1>
+      <a:accent2>
+        <a:srgbClr val="E97132"/>
+      </a:accent2>
+      <a:accent3>
+        <a:srgbClr val="196B24"/>
+      </a:accent3>
+      <a:accent4>
+        <a:srgbClr val="0F9ED5"/>
+      </a:accent4>
+      <a:accent5>
+        <a:srgbClr val="A02B93"/>
+      </a:accent5>
+      <a:accent6>
+        <a:srgbClr val="4EA72E"/>
+      </a:accent6>
+      <a:hlink>
+        <a:srgbClr val="467886"/>
+      </a:hlink>
+      <a:folHlink>
+        <a:srgbClr val="96607D"/>
+      </a:folHlink>
+    </a:clrScheme>
+    <a:fontScheme name="Office">
+      <a:majorFont>
+        <a:latin typeface="Aptos Display" panose="02110004020202020204"/>
+        <a:ea typeface=""/>
+        <a:cs typeface=""/>
+        <a:font script="Jpan" typeface="游ゴシック Light"/>
+        <a:font script="Hang" typeface="맑은 고딕"/>
+        <a:font script="Hans" typeface="等线 Light"/>
+        <a:font script="Hant" typeface="新細明體"/>
+        <a:font script="Arab" typeface="Times New Roman"/>
+        <a:font script="Hebr" typeface="Times New Roman"/>
+        <a:font script="Thai" typeface="Angsana New"/>
+        <a:font script="Ethi" typeface="Nyala"/>
+        <a:font script="Beng" typeface="Vrinda"/>
+        <a:font script="Gujr" typeface="Shruti"/>
+        <a:font script="Khmr" typeface="MoolBoran"/>
+        <a:font script="Knda" typeface="Tunga"/>
+        <a:font script="Guru" typeface="Raavi"/>
+        <a:font script="Cans" typeface="Euphemia"/>
+        <a:font script="Cher" typeface="Plantagenet Cherokee"/>
+        <a:font script="Yiii" typeface="Microsoft Yi Baiti"/>
+        <a:font script="Tibt" typeface="Microsoft Himalaya"/>
+        <a:font script="Thaa" typeface="MV Boli"/>
+        <a:font script="Deva" typeface="Mangal"/>
+        <a:font script="Telu" typeface="Gautami"/>
+        <a:font script="Taml" typeface="Latha"/>
+        <a:font script="Syrc" typeface="Estrangelo Edessa"/>
+        <a:font script="Orya" typeface="Kalinga"/>
+        <a:font script="Mlym" typeface="Kartika"/>
+        <a:font script="Laoo" typeface="DokChampa"/>
+        <a:font script="Sinh" typeface="Iskoola Pota"/>
+        <a:font script="Mong" typeface="Mongolian Baiti"/>
+        <a:font script="Viet" typeface="Times New Roman"/>
+        <a:font script="Uigh" typeface="Microsoft Uighur"/>
+        <a:font script="Geor" typeface="Sylfaen"/>
+        <a:font script="Armn" typeface="Arial"/>
+        <a:font script="Bugi" typeface="Leelawadee UI"/>
+        <a:font script="Bopo" typeface="Microsoft JhengHei"/>
+        <a:font script="Java" typeface="Javanese Text"/>
+        <a:font script="Lisu" typeface="Segoe UI"/>
+        <a:font script="Mymr" typeface="Myanmar Text"/>
+        <a:font script="Nkoo" typeface="Ebrima"/>
+        <a:font script="Olck" typeface="Nirmala UI"/>
+        <a:font script="Osma" typeface="Ebrima"/>
+        <a:font script="Phag" typeface="Phagspa"/>
+        <a:font script="Syrn" typeface="Estrangelo Edessa"/>
+        <a:font script="Syrj" typeface="Estrangelo Edessa"/>
+        <a:font script="Syre" typeface="Estrangelo Edessa"/>
+        <a:font script="Sora" typeface="Nirmala UI"/>
+        <a:font script="Tale" typeface="Microsoft Tai Le"/>
+        <a:font script="Talu" typeface="Microsoft New Tai Lue"/>
+        <a:font script="Tfng" typeface="Ebrima"/>
+      </a:majorFont>
+      <a:minorFont>
+        <a:latin typeface="Aptos" panose="02110004020202020204"/>
+        <a:ea typeface=""/>
+        <a:cs typeface=""/>
+        <a:font script="Jpan" typeface="游ゴシック"/>
+        <a:font script="Hang" typeface="맑은 고딕"/>
+        <a:font script="Hans" typeface="等线"/>
+        <a:font script="Hant" typeface="新細明體"/>
+        <a:font script="Arab" typeface="Arial"/>
+        <a:font script="Hebr" typeface="Arial"/>
+        <a:font script="Thai" typeface="Cordia New"/>
+        <a:font script="Ethi" typeface="Nyala"/>
+        <a:font script="Beng" typeface="Vrinda"/>
+        <a:font script="Gujr" typeface="Shruti"/>
+        <a:font script="Khmr" typeface="DaunPenh"/>
+        <a:font script="Knda" typeface="Tunga"/>
+        <a:font script="Guru" typeface="Raavi"/>
+        <a:font script="Cans" typeface="Euphemia"/>
+        <a:font script="Cher" typeface="Plantagenet Cherokee"/>
+        <a:font script="Yiii" typeface="Microsoft Yi Baiti"/>
+        <a:font script="Tibt" typeface="Microsoft Himalaya"/>
+        <a:font script="Thaa" typeface="MV Boli"/>
+        <a:font script="Deva" typeface="Mangal"/>
+        <a:font script="Telu" typeface="Gautami"/>
+        <a:font script="Taml" typeface="Latha"/>
+        <a:font script="Syrc" typeface="Estrangelo Edessa"/>
+        <a:font script="Orya" typeface="Kalinga"/>
+        <a:font script="Mlym" typeface="Kartika"/>
+        <a:font script="Laoo" typeface="DokChampa"/>
+        <a:font script="Sinh" typeface="Iskoola Pota"/>
+        <a:font script="Mong" typeface="Mongolian Baiti"/>
+        <a:font script="Viet" typeface="Arial"/>
+        <a:font script="Uigh" typeface="Microsoft Uighur"/>
+        <a:font script="Geor" typeface="Sylfaen"/>
+        <a:font script="Armn" typeface="Arial"/>
+        <a:font script="Bugi" typeface="Leelawadee UI"/>
+        <a:font script="Bopo" typeface="Microsoft JhengHei"/>
+        <a:font script="Java" typeface="Javanese Text"/>
+        <a:font script="Lisu" typeface="Segoe UI"/>
+        <a:font script="Mymr" typeface="Myanmar Text"/>
+        <a:font script="Nkoo" typeface="Ebrima"/>
+        <a:font script="Olck" typeface="Nirmala UI"/>
+        <a:font script="Osma" typeface="Ebrima"/>
+        <a:font script="Phag" typeface="Phagspa"/>
+        <a:font script="Syrn" typeface="Estrangelo Edessa"/>
+        <a:font script="Syrj" typeface="Estrangelo Edessa"/>
+        <a:font script="Syre" typeface="Estrangelo Edessa"/>
+        <a:font script="Sora" typeface="Nirmala UI"/>
+        <a:font script="Tale" typeface="Microsoft Tai Le"/>
+        <a:font script="Talu" typeface="Microsoft New Tai Lue"/>
+        <a:font script="Tfng" typeface="Ebrima"/>
+      </a:minorFont>
+    </a:fontScheme>
+    <a:fmtScheme name="Office">
+      <a:fillStyleLst>
+        <a:solidFill>
+          <a:schemeClr val="phClr"/>
+        </a:solidFill>
+        <a:gradFill rotWithShape="1">
+          <a:gsLst>
+            <a:gs pos="0">
+              <a:schemeClr val="phClr">
+                <a:lumMod val="110000"/>
+                <a:satMod val="105000"/>
+                <a:tint val="67000"/>
+              </a:schemeClr>
+            </a:gs>
+            <a:gs pos="50000">
+              <a:schemeClr val="phClr">
+                <a:lumMod val="105000"/>
+                <a:satMod val="103000"/>
+                <a:tint val="73000"/>
+              </a:schemeClr>
+            </a:gs>
+            <a:gs pos="100000">
+              <a:schemeClr val="phClr">
+                <a:lumMod val="105000"/>
+                <a:satMod val="109000"/>
+                <a:tint val="81000"/>
+              </a:schemeClr>
+            </a:gs>
+          </a:gsLst>
+          <a:lin ang="5400000" scaled="0"/>
+        </a:gradFill>
+        <a:gradFill rotWithShape="1">
+          <a:gsLst>
+            <a:gs pos="0">
+              <a:schemeClr val="phClr">
+                <a:satMod val="103000"/>
+                <a:lumMod val="102000"/>
+                <a:tint val="94000"/>
+              </a:schemeClr>
+            </a:gs>
+            <a:gs pos="50000">
+              <a:schemeClr val="phClr">
+                <a:satMod val="110000"/>
+                <a:lumMod val="100000"/>
+                <a:shade val="100000"/>
+              </a:schemeClr>
+            </a:gs>
+            <a:gs pos="100000">
+              <a:schemeClr val="phClr">
+                <a:lumMod val="99000"/>
+                <a:satMod val="120000"/>
+                <a:shade val="78000"/>
+              </a:schemeClr>
+            </a:gs>
+          </a:gsLst>
+          <a:lin ang="5400000" scaled="0"/>
+        </a:gradFill>
+      </a:fillStyleLst>
+      <a:lnStyleLst>
+        <a:ln w="12700" cap="flat" cmpd="sng" algn="ctr">
+          <a:solidFill>
+            <a:schemeClr val="phClr"/>
+          </a:solidFill>
+          <a:prstDash val="solid"/>
+          <a:miter lim="800000"/>
+        </a:ln>
+        <a:ln w="19050" cap="flat" cmpd="sng" algn="ctr">
+          <a:solidFill>
+            <a:schemeClr val="phClr"/>
+          </a:solidFill>
+          <a:prstDash val="solid"/>
+          <a:miter lim="800000"/>
+        </a:ln>
+        <a:ln w="25400" cap="flat" cmpd="sng" algn="ctr">
+          <a:solidFill>
+            <a:schemeClr val="phClr"/>
+          </a:solidFill>
+          <a:prstDash val="solid"/>
+          <a:miter lim="800000"/>
+        </a:ln>
+      </a:lnStyleLst>
+      <a:effectStyleLst>
+        <a:effectStyle>
+          <a:effectLst/>
+        </a:effectStyle>
+        <a:effectStyle>
+          <a:effectLst/>
+        </a:effectStyle>
+        <a:effectStyle>
+          <a:effectLst>
+            <a:outerShdw blurRad="57150" dist="19050" dir="5400000" algn="ctr" rotWithShape="0">
+              <a:srgbClr val="000000">
+                <a:alpha val="63000"/>
+              </a:srgbClr>
+            </a:outerShdw>
+          </a:effectLst>
+        </a:effectStyle>
+      </a:effectStyleLst>
+      <a:bgFillStyleLst>
+        <a:solidFill>
+          <a:schemeClr val="phClr"/>
+        </a:solidFill>
+        <a:solidFill>
+          <a:schemeClr val="phClr">
+            <a:tint val="95000"/>
+            <a:satMod val="170000"/>
+          </a:schemeClr>
+        </a:solidFill>
+        <a:gradFill rotWithShape="1">
+          <a:gsLst>
+            <a:gs pos="0">
+              <a:schemeClr val="phClr">
+                <a:tint val="93000"/>
+                <a:satMod val="150000"/>
+                <a:shade val="98000"/>
+                <a:lumMod val="102000"/>
+              </a:schemeClr>
+            </a:gs>
+            <a:gs pos="50000">
+              <a:schemeClr val="phClr">
+                <a:tint val="98000"/>
+                <a:satMod val="130000"/>
+                <a:shade val="90000"/>
+                <a:lumMod val="103000"/>
+              </a:schemeClr>
+            </a:gs>
+            <a:gs pos="100000">
+              <a:schemeClr val="phClr">
+                <a:shade val="63000"/>
+                <a:satMod val="120000"/>
+              </a:schemeClr>
+            </a:gs>
+          </a:gsLst>
+          <a:lin ang="5400000" scaled="0"/>
+        </a:gradFill>
+      </a:bgFillStyleLst>
+    </a:fmtScheme>
+  </a:themeElements>
+  <a:objectDefaults>
+    <a:lnDef>
+      <a:spPr/>
+      <a:bodyPr/>
+      <a:lstStyle/>
+      <a:style>
+        <a:lnRef idx="2">
+          <a:schemeClr val="accent1"/>
+        </a:lnRef>
+        <a:fillRef idx="0">
+          <a:schemeClr val="accent1"/>
+        </a:fillRef>
+        <a:effectRef idx="1">
+          <a:schemeClr val="accent1"/>
+        </a:effectRef>
+        <a:fontRef idx="minor">
+          <a:schemeClr val="tx1"/>
+        </a:fontRef>
+      </a:style>
+    </a:lnDef>
+  </a:objectDefaults>
+  <a:extraClrSchemeLst/>
+  <a:extLst>
+    <a:ext uri="{05A4C25C-085E-4340-85A3-A5531E510DB2}">
+      <thm15:themeFamily xmlns:thm15="http://schemas.microsoft.com/office/thememl/2012/main" name="Office Theme" id="{2E142A2C-CD16-42D6-873A-C26D2A0506FA}" vid="{1BDDFF52-6CD6-40A5-AB3C-68EB2F1E4D0A}"/>
+    </a:ext>
+  </a:extLst>
+</a:theme>
 </file>
</xml_diff>

<commit_message>
Flyer: adopt III-Jornadas series background (watermark + magenta corner, white UGR)
Co-Authored-By: claude-flow <ruv@ruv.net>
</commit_message>
<xml_diff>
--- a/flyer/IV_Jornadas_DiD_flyer.pptx
+++ b/flyer/IV_Jornadas_DiD_flyer.pptx
@@ -638,9 +638,12 @@
   <p:cSld name="Slide 1">
     <p:bg>
       <p:bgPr>
-        <a:solidFill>
-          <a:srgbClr val="FFFFFF"/>
-        </a:solidFill>
+        <a:blipFill>
+          <a:blip r:embed="rId8"/>
+          <a:stretch>
+            <a:fillRect/>
+          </a:stretch>
+        </a:blipFill>
         <a:effectLst/>
       </p:bgPr>
     </p:bg>
@@ -660,114 +663,6 @@
       </p:grpSpPr>
       <p:sp>
         <p:nvSpPr>
-          <p:cNvPr id="2" name="Shape 0"/>
-          <p:cNvSpPr/>
-          <p:nvPr/>
-        </p:nvSpPr>
-        <p:spPr>
-          <a:xfrm>
-            <a:off x="146304" y="128016"/>
-            <a:ext cx="164592" cy="164592"/>
-          </a:xfrm>
-          <a:prstGeom prst="ellipse">
-            <a:avLst/>
-          </a:prstGeom>
-          <a:solidFill>
-            <a:srgbClr val="FFE8D5">
-              <a:alpha val="92000"/>
-            </a:srgbClr>
-          </a:solidFill>
-          <a:ln w="12700">
-            <a:solidFill>
-              <a:srgbClr val="FFE8D5">
-                <a:alpha val="0"/>
-              </a:srgbClr>
-            </a:solidFill>
-            <a:prstDash val="solid"/>
-          </a:ln>
-        </p:spPr>
-        <p:txBody>
-          <a:bodyPr/>
-          <a:lstStyle/>
-          <a:p>
-            <a:endParaRPr/>
-          </a:p>
-        </p:txBody>
-      </p:sp>
-      <p:sp>
-        <p:nvSpPr>
-          <p:cNvPr id="3" name="Shape 1"/>
-          <p:cNvSpPr/>
-          <p:nvPr/>
-        </p:nvSpPr>
-        <p:spPr>
-          <a:xfrm>
-            <a:off x="6446520" y="201168"/>
-            <a:ext cx="219456" cy="219456"/>
-          </a:xfrm>
-          <a:prstGeom prst="ellipse">
-            <a:avLst/>
-          </a:prstGeom>
-          <a:solidFill>
-            <a:srgbClr val="E9BBD0">
-              <a:alpha val="92000"/>
-            </a:srgbClr>
-          </a:solidFill>
-          <a:ln w="12700">
-            <a:solidFill>
-              <a:srgbClr val="E9BBD0">
-                <a:alpha val="0"/>
-              </a:srgbClr>
-            </a:solidFill>
-            <a:prstDash val="solid"/>
-          </a:ln>
-        </p:spPr>
-        <p:txBody>
-          <a:bodyPr/>
-          <a:lstStyle/>
-          <a:p>
-            <a:endParaRPr/>
-          </a:p>
-        </p:txBody>
-      </p:sp>
-      <p:sp>
-        <p:nvSpPr>
-          <p:cNvPr id="4" name="Shape 2"/>
-          <p:cNvSpPr/>
-          <p:nvPr/>
-        </p:nvSpPr>
-        <p:spPr>
-          <a:xfrm>
-            <a:off x="6291072" y="5870448"/>
-            <a:ext cx="146304" cy="146304"/>
-          </a:xfrm>
-          <a:prstGeom prst="ellipse">
-            <a:avLst/>
-          </a:prstGeom>
-          <a:solidFill>
-            <a:srgbClr val="FFE0C2">
-              <a:alpha val="82000"/>
-            </a:srgbClr>
-          </a:solidFill>
-          <a:ln w="12700">
-            <a:solidFill>
-              <a:srgbClr val="FFE0C2">
-                <a:alpha val="0"/>
-              </a:srgbClr>
-            </a:solidFill>
-            <a:prstDash val="solid"/>
-          </a:ln>
-        </p:spPr>
-        <p:txBody>
-          <a:bodyPr/>
-          <a:lstStyle/>
-          <a:p>
-            <a:endParaRPr/>
-          </a:p>
-        </p:txBody>
-      </p:sp>
-      <p:sp>
-        <p:nvSpPr>
           <p:cNvPr id="5" name="Text 3"/>
           <p:cNvSpPr/>
           <p:nvPr/>
@@ -1587,8 +1482,8 @@
         </p:blipFill>
         <p:spPr>
           <a:xfrm>
-            <a:off x="246888" y="6254496"/>
-            <a:ext cx="749808" cy="502920"/>
+            <a:off x="152400" y="6400800"/>
+            <a:ext cx="1524000" cy="433700"/>
           </a:xfrm>
           <a:prstGeom prst="rect">
             <a:avLst/>

</xml_diff>

<commit_message>
Flyer: use exact III-Jornadas background assets for a true series match
Co-Authored-By: claude-flow <ruv@ruv.net>
</commit_message>
<xml_diff>
--- a/flyer/IV_Jornadas_DiD_flyer.pptx
+++ b/flyer/IV_Jornadas_DiD_flyer.pptx
@@ -1482,8 +1482,8 @@
         </p:blipFill>
         <p:spPr>
           <a:xfrm>
-            <a:off x="152400" y="6400800"/>
-            <a:ext cx="1524000" cy="433700"/>
+            <a:off x="35730" y="6314000"/>
+            <a:ext cx="864400" cy="568100"/>
           </a:xfrm>
           <a:prstGeom prst="rect">
             <a:avLst/>
@@ -1506,8 +1506,8 @@
         </p:blipFill>
         <p:spPr>
           <a:xfrm>
-            <a:off x="2505456" y="6327648"/>
-            <a:ext cx="1673352" cy="475488"/>
+            <a:off x="2607700" y="6436000"/>
+            <a:ext cx="1521800" cy="388300"/>
           </a:xfrm>
           <a:prstGeom prst="rect">
             <a:avLst/>
@@ -1530,8 +1530,8 @@
         </p:blipFill>
         <p:spPr>
           <a:xfrm>
-            <a:off x="4983480" y="6300216"/>
-            <a:ext cx="1609344" cy="475488"/>
+            <a:off x="5222100" y="6220600"/>
+            <a:ext cx="1571600" cy="582500"/>
           </a:xfrm>
           <a:prstGeom prst="rect">
             <a:avLst/>

</xml_diff>

<commit_message>
Inscription: wire live Google Form link (webpage + flyer)
- Webpage: set FORM_URL to https://forms.gle/MQwX7m5SToPd9qHn7 — all
  "Inscripción" buttons now open the form (target _blank); primary CTA
  reads "Completar inscripción" and the note shows the form URL.
- Flyer: "Gratuita · próximamente" -> "Gratuita · abierta" and added the
  short link forms.gle/MQwX7m5SToPd9qHn7; PPTX rebuilt, preview updated.

Co-Authored-By: claude-flow <ruv@ruv.net>
</commit_message>
<xml_diff>
--- a/flyer/IV_Jornadas_DiD_flyer.pptx
+++ b/flyer/IV_Jornadas_DiD_flyer.pptx
@@ -1560,7 +1560,7 @@
                 <a:ea typeface="Aptos" pitchFamily="34" charset="-122"/>
                 <a:cs typeface="Aptos" pitchFamily="34" charset="-120"/>
               </a:rPr>
-              <a:t>· próximamente</a:t>
+              <a:t>· abierta</a:t>
             </a:r>
             <a:endParaRPr lang="en-US" sz="1420" dirty="0"/>
           </a:p>
@@ -1575,7 +1575,7 @@
         <p:spPr>
           <a:xfrm>
             <a:off x="457200" y="6163056"/>
-            <a:ext cx="2476195" cy="152705"/>
+            <a:ext cx="2857500" cy="152705"/>
           </a:xfrm>
           <a:prstGeom prst="rect">
             <a:avLst/>
@@ -1599,7 +1599,7 @@
                 <a:ea typeface="Aptos" pitchFamily="34" charset="-122"/>
                 <a:cs typeface="Aptos" pitchFamily="34" charset="-120"/>
               </a:rPr>
-              <a:t>Aforo limitado · acceso abierto</a:t>
+              <a:t>forms.gle/MQwX7m5SToPd9qHn7</a:t>
             </a:r>
             <a:endParaRPr lang="en-US" sz="960" dirty="0"/>
           </a:p>

</xml_diff>

<commit_message>
Speaker: correct Lídia Farré's affiliation (not catedrática)
Per the speaker's correction, the title is Científica Titular (IAE-CSIC)
and Associate Research Professor (Barcelona School of Economics), not
"Catedrática de Universidad · Economía Aplicada".

- Webpage: speaker block now lists each role with its institution; added
  JSON-LD jobTitle. (Social meta already named IAE-CSIC/BSE — unchanged.)
- Flyer: two-line affiliation (PPTX rebuilt + preview mirrored).

Co-Authored-By: claude-flow <ruv@ruv.net>
</commit_message>
<xml_diff>
--- a/flyer/IV_Jornadas_DiD_flyer.pptx
+++ b/flyer/IV_Jornadas_DiD_flyer.pptx
@@ -1250,8 +1250,8 @@
         </p:nvSpPr>
         <p:spPr>
           <a:xfrm>
-            <a:off x="1790395" y="3914546"/>
-            <a:ext cx="3429000" cy="190195"/>
+            <a:off x="1790395" y="3905402"/>
+            <a:ext cx="4304995" cy="323698"/>
           </a:xfrm>
           <a:prstGeom prst="rect">
             <a:avLst/>
@@ -1264,10 +1264,13 @@
           <a:lstStyle/>
           <a:p>
             <a:pPr indent="0" marL="0">
-              <a:buNone/>
-            </a:pPr>
-            <a:r>
-              <a:rPr lang="en-US" sz="1120" dirty="0">
+              <a:lnSpc>
+                <a:spcPct val="108000"/>
+              </a:lnSpc>
+              <a:buNone/>
+            </a:pPr>
+            <a:r>
+              <a:rPr lang="en-US" sz="1080" dirty="0">
                 <a:solidFill>
                   <a:srgbClr val="5B5B5B"/>
                 </a:solidFill>
@@ -1275,9 +1278,29 @@
                 <a:ea typeface="Aptos" pitchFamily="34" charset="-122"/>
                 <a:cs typeface="Aptos" pitchFamily="34" charset="-120"/>
               </a:rPr>
-              <a:t>Catedrática de Universidad · Economía Aplicada</a:t>
-            </a:r>
-            <a:endParaRPr lang="en-US" sz="1120" dirty="0"/>
+              <a:t>Científica Titular · IAE-CSIC</a:t>
+            </a:r>
+            <a:endParaRPr lang="en-US" sz="1080" dirty="0"/>
+          </a:p>
+          <a:p>
+            <a:pPr indent="0" marL="0">
+              <a:lnSpc>
+                <a:spcPct val="108000"/>
+              </a:lnSpc>
+              <a:buNone/>
+            </a:pPr>
+            <a:r>
+              <a:rPr lang="en-US" sz="1080" dirty="0">
+                <a:solidFill>
+                  <a:srgbClr val="5B5B5B"/>
+                </a:solidFill>
+                <a:latin typeface="Aptos" pitchFamily="34" charset="0"/>
+                <a:ea typeface="Aptos" pitchFamily="34" charset="-122"/>
+                <a:cs typeface="Aptos" pitchFamily="34" charset="-120"/>
+              </a:rPr>
+              <a:t>Associate Research Professor · Barcelona School of Economics</a:t>
+            </a:r>
+            <a:endParaRPr lang="en-US" sz="1080" dirty="0"/>
           </a:p>
         </p:txBody>
       </p:sp>

</xml_diff>